<commit_message>
Refresh all web UI screenshots and the presentation (Python MapReduce, DataFrame-only dashboard)
</commit_message>
<xml_diff>
--- a/docs/ClimaFlu_Final_Review.pptx
+++ b/docs/ClimaFlu_Final_Review.pptx
@@ -120,14 +120,14 @@
   <p:extLst>
     <p:ext uri="{521415D9-36F7-43E2-AB2F-B90AF26B5E84}">
       <p14:sectionLst xmlns:p14="http://schemas.microsoft.com/office/powerpoint/2010/main">
-        <p14:section name="Introduction" id="{fa310e13-d96d-27d9-d44a-5d8ad2eabdaa}">
+        <p14:section name="Introduction" id="{970ba5ae-2c24-271a-c7d9-8bd107f9ddb9}">
           <p14:sldIdLst>
             <p14:sldId id="256"/>
             <p14:sldId id="257"/>
             <p14:sldId id="258"/>
           </p14:sldIdLst>
         </p14:section>
-        <p14:section name="Architecture and Spark" id="{2e27e69a-7630-69d7-aaba-43de1d4b9e16}">
+        <p14:section name="Architecture and Spark" id="{6c2a2627-5e47-3d1e-a19d-6971714e4a3e}">
           <p14:sldIdLst>
             <p14:sldId id="259"/>
             <p14:sldId id="260"/>
@@ -135,20 +135,20 @@
             <p14:sldId id="262"/>
           </p14:sldIdLst>
         </p14:section>
-        <p14:section name="Machine learning and results" id="{b3a37e80-0b74-2fef-f383-c8e7a550c00e}">
+        <p14:section name="Machine learning and results" id="{2c43e448-80e0-4aab-3f1e-4a803d347b0d}">
           <p14:sldIdLst>
             <p14:sldId id="263"/>
             <p14:sldId id="264"/>
             <p14:sldId id="265"/>
           </p14:sldIdLst>
         </p14:section>
-        <p14:section name="Conclusion" id="{eb8fd491-b3e1-9ed7-3c70-7532a1e2d5c5}">
+        <p14:section name="Conclusion" id="{b03ae917-56b3-d982-0189-5de68bf21db0}">
           <p14:sldIdLst>
             <p14:sldId id="266"/>
             <p14:sldId id="267"/>
           </p14:sldIdLst>
         </p14:section>
-        <p14:section name="Backup" id="{b3a99bc2-4e45-532b-e008-5565b6bbd79f}">
+        <p14:section name="Backup" id="{4c808740-138a-2673-40e0-8b9f25887bee}">
           <p14:sldIdLst>
             <p14:sldId id="268"/>
             <p14:sldId id="269"/>
@@ -6020,8 +6020,8 @@
         </p:blipFill>
         <p:spPr>
           <a:xfrm>
-            <a:off x="844357" y="1280160"/>
-            <a:ext cx="4803526" cy="4206240"/>
+            <a:off x="855924" y="1280160"/>
+            <a:ext cx="4780392" cy="4206240"/>
           </a:xfrm>
           <a:prstGeom prst="rect">
             <a:avLst/>

</xml_diff>